<commit_message>
vault backup: 2026-10-28 17:47:07
</commit_message>
<xml_diff>
--- a/Claude outputs/Enhancing resilience of food systems in Vietnam.pptx
+++ b/Claude outputs/Enhancing resilience of food systems in Vietnam.pptx
@@ -12,6 +12,7 @@
     <p:sldId id="257" r:id="rId3"/>
     <p:sldId id="282" r:id="rId19"/>
     <p:sldId id="283" r:id="rId20"/>
+    <p:sldId id="291" r:id="rId28"/>
     <p:sldId id="281" r:id="rId4"/>
     <p:sldId id="284" r:id="rId21"/>
     <p:sldId id="285" r:id="rId22"/>
@@ -932,6 +933,116 @@
           <a:p>
             <a:r>
               <a:t>Acknowledgements: add partners, funders and logos here.</a:t>
+            </a:r>
+          </a:p>
+        </p:txBody>
+      </p:sp>
+      <p:sp>
+        <p:nvSpPr>
+          <p:cNvPr id="4" name="Slide Number Placeholder 3"/>
+          <p:cNvSpPr>
+            <a:spLocks noGrp="1"/>
+          </p:cNvSpPr>
+          <p:nvPr>
+            <p:ph type="sldNum" idx="5" sz="quarter"/>
+          </p:nvPr>
+        </p:nvSpPr>
+        <p:spPr/>
+      </p:sp>
+    </p:spTree>
+  </p:cSld>
+  <p:clrMapOvr>
+    <a:masterClrMapping/>
+  </p:clrMapOvr>
+</p:notes>
+</file>
+
+<file path=ppt/notesSlides/notesSlide13.xml><?xml version="1.0" encoding="utf-8"?>
+<p:notes xmlns:a="http://schemas.openxmlformats.org/drawingml/2006/main" xmlns:p="http://schemas.openxmlformats.org/presentationml/2006/main" xmlns:r="http://schemas.openxmlformats.org/officeDocument/2006/relationships">
+  <p:cSld>
+    <p:spTree>
+      <p:nvGrpSpPr>
+        <p:cNvPr id="1" name=""/>
+        <p:cNvGrpSpPr/>
+        <p:nvPr/>
+      </p:nvGrpSpPr>
+      <p:grpSpPr>
+        <a:xfrm>
+          <a:off x="0" y="0"/>
+          <a:ext cx="0" cy="0"/>
+          <a:chOff x="0" y="0"/>
+          <a:chExt cx="0" cy="0"/>
+        </a:xfrm>
+      </p:grpSpPr>
+      <p:sp>
+        <p:nvSpPr>
+          <p:cNvPr id="2" name="Slide Image Placeholder 1"/>
+          <p:cNvSpPr>
+            <a:spLocks noGrp="1"/>
+          </p:cNvSpPr>
+          <p:nvPr>
+            <p:ph type="sldImg" idx="2"/>
+          </p:nvPr>
+        </p:nvSpPr>
+        <p:spPr/>
+      </p:sp>
+      <p:sp>
+        <p:nvSpPr>
+          <p:cNvPr id="3" name="Notes Placeholder 2"/>
+          <p:cNvSpPr>
+            <a:spLocks noGrp="1"/>
+          </p:cNvSpPr>
+          <p:nvPr>
+            <p:ph type="body" idx="3" sz="quarter"/>
+          </p:nvPr>
+        </p:nvSpPr>
+        <p:spPr/>
+        <p:txBody>
+          <a:bodyPr/>
+          <a:lstStyle/>
+          <a:p>
+            <a:r>
+              <a:t>Seven generic principles for enhancing resilience (Biggs et al., 2012, Annual Review of Environment and Resources 37): (P1) maintain diversity and redundancy, (P2) manage connectivity, (P3) manage slow variables and feedbacks, (P4) foster an understanding of social-ecological systems as complex adaptive systems, (P5) encourage learning and experimentation, (P6) broaden participation, (P7) promote polycentric governance. On the slide, P4 and P5 are combined. The principles often co-occur and depend on each other.</a:t>
+            </a:r>
+          </a:p>
+          <a:p>
+            <a:r>
+              <a:t>Viet Nam examples (critical reading):</a:t>
+            </a:r>
+          </a:p>
+          <a:p>
+            <a:r>
+              <a:t>1. Diversity and redundancy (+): in Moc Chau (Son La), diverse food sources, decentralised flows and low reliance on external inputs kept the local food system working during COVID-19 (Bruckert &amp; Nguyen, 2024). Hertel et al. (2021) call diversification the most fundamental lever.</a:t>
+            </a:r>
+          </a:p>
+          <a:p>
+            <a:r>
+              <a:t>2. Connectivity (-): connectivity can spread or dampen shocks. In 2007-08, export restrictions by major exporters, Viet Nam among them, helped turn an adequately supplied rice market into a price spike (Dawe &amp; Slayton, 2011).</a:t>
+            </a:r>
+          </a:p>
+          <a:p>
+            <a:r>
+              <a:t>3. Slow variables (-): in the coastal Mekong Delta, rising salinity is a slow stress; farmers' recovery depends on credit, off-farm income and fresh water, and rice-oriented policy makes it harder to change systems (Nguyen et al., 2019). Land degradation in Moc Chau is another slow variable.</a:t>
+            </a:r>
+          </a:p>
+          <a:p>
+            <a:r>
+              <a:t>4. Learning and experimentation (+): Son La and Dong Thap piloted provincial food system profiles and priority-setting before a provincial plan was approved (Son La 161/KH-UBND, 2025) (Lundy et al., 2026).</a:t>
+            </a:r>
+          </a:p>
+          <a:p>
+            <a:r>
+              <a:t>5. Participation (-): in Ca Mau, shrimp-mangrove and fisheries policies aimed at social-ecological resilience did not necessarily raise households' social and economic resilience; control and enforcement alone are not enough (Tran, 2012).</a:t>
+            </a:r>
+          </a:p>
+          <a:p>
+            <a:r>
+              <a:t>6. Polycentric governance (+, with a caveat): NAP-FST links national ministries, provinces and the FST-Partnership, but most localities still lack dedicated funding and staff (MAE, 2025).</a:t>
+            </a:r>
+          </a:p>
+          <a:p>
+            <a:r>
+              <a:t>Key message: the principles help, but they can pull against each other (e.g. trade connectivity vs self-sufficiency), so trade-offs have to be negotiated (Zurek et al., 2022).</a:t>
             </a:r>
           </a:p>
         </p:txBody>
@@ -12716,6 +12827,1461 @@
                 <a:latin typeface="Calibri"/>
               </a:rPr>
               <a:t>Acknowledgements</a:t>
+            </a:r>
+          </a:p>
+        </p:txBody>
+      </p:sp>
+    </p:spTree>
+  </p:cSld>
+  <p:clrMapOvr>
+    <a:masterClrMapping/>
+  </p:clrMapOvr>
+</p:sld>
+</file>
+
+<file path=ppt/slides/slide22.xml><?xml version="1.0" encoding="utf-8"?>
+<p:sld xmlns:a="http://schemas.openxmlformats.org/drawingml/2006/main" xmlns:p="http://schemas.openxmlformats.org/presentationml/2006/main" xmlns:r="http://schemas.openxmlformats.org/officeDocument/2006/relationships">
+  <p:cSld>
+    <p:spTree>
+      <p:nvGrpSpPr>
+        <p:cNvPr id="1" name=""/>
+        <p:cNvGrpSpPr/>
+        <p:nvPr/>
+      </p:nvGrpSpPr>
+      <p:grpSpPr/>
+      <p:sp>
+        <p:nvSpPr>
+          <p:cNvPr id="2" name="Title"/>
+          <p:cNvSpPr txBox="1"/>
+          <p:nvPr/>
+        </p:nvSpPr>
+        <p:spPr>
+          <a:xfrm>
+            <a:off x="548640" y="365760"/>
+            <a:ext cx="11064240" cy="731520"/>
+          </a:xfrm>
+          <a:prstGeom prst="rect">
+            <a:avLst/>
+          </a:prstGeom>
+          <a:noFill/>
+        </p:spPr>
+        <p:txBody>
+          <a:bodyPr wrap="square" lIns="0" rIns="0" tIns="0" bIns="0" anchor="t">
+            <a:spAutoFit/>
+          </a:bodyPr>
+          <a:lstStyle/>
+          <a:p>
+            <a:pPr algn="l"/>
+            <a:r>
+              <a:rPr sz="3200" b="1" i="0">
+                <a:solidFill>
+                  <a:srgbClr val="15607A"/>
+                </a:solidFill>
+                <a:latin typeface="Calibri"/>
+              </a:rPr>
+              <a:t>Principles for building resilient food systems</a:t>
+            </a:r>
+          </a:p>
+        </p:txBody>
+      </p:sp>
+      <p:sp>
+        <p:nvSpPr>
+          <p:cNvPr id="3" name="TextBox 2"/>
+          <p:cNvSpPr txBox="1"/>
+          <p:nvPr/>
+        </p:nvSpPr>
+        <p:spPr>
+          <a:xfrm>
+            <a:off x="548640" y="1051560"/>
+            <a:ext cx="11064240" cy="365760"/>
+          </a:xfrm>
+          <a:prstGeom prst="rect">
+            <a:avLst/>
+          </a:prstGeom>
+          <a:noFill/>
+        </p:spPr>
+        <p:txBody>
+          <a:bodyPr wrap="square" lIns="0" rIns="0" tIns="0" bIns="0" anchor="t">
+            <a:spAutoFit/>
+          </a:bodyPr>
+          <a:lstStyle/>
+          <a:p>
+            <a:pPr algn="l"/>
+            <a:r>
+              <a:rPr sz="1500" b="0" i="1">
+                <a:solidFill>
+                  <a:srgbClr val="6B757D"/>
+                </a:solidFill>
+                <a:latin typeface="Calibri"/>
+              </a:rPr>
+              <a:t>Adapted from Biggs et al. (2012), with examples from Viet Nam  (+ what worked, – a warning)</a:t>
+            </a:r>
+          </a:p>
+        </p:txBody>
+      </p:sp>
+      <p:sp>
+        <p:nvSpPr>
+          <p:cNvPr id="4" name="Principle card 1"/>
+          <p:cNvSpPr/>
+          <p:nvPr/>
+        </p:nvSpPr>
+        <p:spPr>
+          <a:xfrm>
+            <a:off x="548640" y="1600200"/>
+            <a:ext cx="3474720" cy="2011680"/>
+          </a:xfrm>
+          <a:prstGeom prst="roundRect">
+            <a:avLst>
+              <a:gd name="adj" fmla="val 8000"/>
+            </a:avLst>
+          </a:prstGeom>
+          <a:solidFill>
+            <a:srgbClr val="FFFFFF"/>
+          </a:solidFill>
+          <a:ln w="12700">
+            <a:solidFill>
+              <a:srgbClr val="D5DBDF"/>
+            </a:solidFill>
+          </a:ln>
+          <a:effectLst/>
+        </p:spPr>
+        <p:style>
+          <a:lnRef idx="1">
+            <a:schemeClr val="accent1"/>
+          </a:lnRef>
+          <a:fillRef idx="3">
+            <a:schemeClr val="accent1"/>
+          </a:fillRef>
+          <a:effectRef idx="2">
+            <a:schemeClr val="accent1"/>
+          </a:effectRef>
+          <a:fontRef idx="minor">
+            <a:schemeClr val="lt1"/>
+          </a:fontRef>
+        </p:style>
+        <p:txBody>
+          <a:bodyPr rtlCol="0" anchor="ctr"/>
+          <a:lstStyle/>
+          <a:p/>
+        </p:txBody>
+      </p:sp>
+      <p:sp>
+        <p:nvSpPr>
+          <p:cNvPr id="5" name="Oval 4"/>
+          <p:cNvSpPr/>
+          <p:nvPr/>
+        </p:nvSpPr>
+        <p:spPr>
+          <a:xfrm>
+            <a:off x="777240" y="1828800"/>
+            <a:ext cx="548640" cy="548640"/>
+          </a:xfrm>
+          <a:prstGeom prst="ellipse">
+            <a:avLst/>
+          </a:prstGeom>
+          <a:solidFill>
+            <a:srgbClr val="15607A"/>
+          </a:solidFill>
+          <a:ln>
+            <a:noFill/>
+          </a:ln>
+          <a:effectLst/>
+        </p:spPr>
+        <p:style>
+          <a:lnRef idx="1">
+            <a:schemeClr val="accent1"/>
+          </a:lnRef>
+          <a:fillRef idx="3">
+            <a:schemeClr val="accent1"/>
+          </a:fillRef>
+          <a:effectRef idx="2">
+            <a:schemeClr val="accent1"/>
+          </a:effectRef>
+          <a:fontRef idx="minor">
+            <a:schemeClr val="lt1"/>
+          </a:fontRef>
+        </p:style>
+        <p:txBody>
+          <a:bodyPr rtlCol="0" anchor="ctr" lIns="0" rIns="0" tIns="0" bIns="0"/>
+          <a:lstStyle/>
+          <a:p>
+            <a:pPr algn="ctr"/>
+            <a:r>
+              <a:rPr sz="1800" b="1">
+                <a:solidFill>
+                  <a:srgbClr val="FFFFFF"/>
+                </a:solidFill>
+                <a:latin typeface="Calibri"/>
+              </a:rPr>
+              <a:t>1</a:t>
+            </a:r>
+          </a:p>
+        </p:txBody>
+      </p:sp>
+      <p:sp>
+        <p:nvSpPr>
+          <p:cNvPr id="6" name="TextBox 5"/>
+          <p:cNvSpPr txBox="1"/>
+          <p:nvPr/>
+        </p:nvSpPr>
+        <p:spPr>
+          <a:xfrm>
+            <a:off x="1463040" y="1828800"/>
+            <a:ext cx="2423160" cy="548640"/>
+          </a:xfrm>
+          <a:prstGeom prst="rect">
+            <a:avLst/>
+          </a:prstGeom>
+          <a:noFill/>
+        </p:spPr>
+        <p:txBody>
+          <a:bodyPr wrap="square" lIns="0" rIns="0" tIns="0" bIns="0" anchor="ctr">
+            <a:spAutoFit/>
+          </a:bodyPr>
+          <a:lstStyle/>
+          <a:p>
+            <a:pPr algn="l"/>
+            <a:r>
+              <a:rPr sz="1700" b="1" i="0">
+                <a:solidFill>
+                  <a:srgbClr val="15607A"/>
+                </a:solidFill>
+                <a:latin typeface="Calibri"/>
+              </a:rPr>
+              <a:t>Keep diversity and redundancy</a:t>
+            </a:r>
+          </a:p>
+        </p:txBody>
+      </p:sp>
+      <p:sp>
+        <p:nvSpPr>
+          <p:cNvPr id="7" name="Sign 1"/>
+          <p:cNvSpPr/>
+          <p:nvPr/>
+        </p:nvSpPr>
+        <p:spPr>
+          <a:xfrm>
+            <a:off x="777240" y="2624328"/>
+            <a:ext cx="347472" cy="347472"/>
+          </a:xfrm>
+          <a:prstGeom prst="ellipse">
+            <a:avLst/>
+          </a:prstGeom>
+          <a:solidFill>
+            <a:srgbClr val="4E8F3A"/>
+          </a:solidFill>
+          <a:ln>
+            <a:noFill/>
+          </a:ln>
+          <a:effectLst/>
+        </p:spPr>
+        <p:style>
+          <a:lnRef idx="1">
+            <a:schemeClr val="accent1"/>
+          </a:lnRef>
+          <a:fillRef idx="3">
+            <a:schemeClr val="accent1"/>
+          </a:fillRef>
+          <a:effectRef idx="2">
+            <a:schemeClr val="accent1"/>
+          </a:effectRef>
+          <a:fontRef idx="minor">
+            <a:schemeClr val="lt1"/>
+          </a:fontRef>
+        </p:style>
+        <p:txBody>
+          <a:bodyPr rtlCol="0" anchor="ctr" lIns="0" rIns="0" tIns="0" bIns="0"/>
+          <a:lstStyle/>
+          <a:p>
+            <a:pPr algn="ctr"/>
+            <a:r>
+              <a:rPr sz="1600" b="1">
+                <a:solidFill>
+                  <a:srgbClr val="FFFFFF"/>
+                </a:solidFill>
+                <a:latin typeface="Calibri"/>
+              </a:rPr>
+              <a:t>+</a:t>
+            </a:r>
+          </a:p>
+        </p:txBody>
+      </p:sp>
+      <p:sp>
+        <p:nvSpPr>
+          <p:cNvPr id="8" name="TextBox 7"/>
+          <p:cNvSpPr txBox="1"/>
+          <p:nvPr/>
+        </p:nvSpPr>
+        <p:spPr>
+          <a:xfrm>
+            <a:off x="1280160" y="2514600"/>
+            <a:ext cx="2606040" cy="1005840"/>
+          </a:xfrm>
+          <a:prstGeom prst="rect">
+            <a:avLst/>
+          </a:prstGeom>
+          <a:noFill/>
+        </p:spPr>
+        <p:txBody>
+          <a:bodyPr wrap="square" lIns="0" rIns="0" tIns="0" bIns="0" anchor="t">
+            <a:spAutoFit/>
+          </a:bodyPr>
+          <a:lstStyle/>
+          <a:p>
+            <a:pPr algn="l"/>
+            <a:r>
+              <a:rPr sz="1400" b="0" i="0">
+                <a:solidFill>
+                  <a:srgbClr val="222B33"/>
+                </a:solidFill>
+                <a:latin typeface="Calibri"/>
+              </a:rPr>
+              <a:t>Moc Chau: diverse food sources and decentralised flows kept food moving during COVID-19</a:t>
+            </a:r>
+          </a:p>
+        </p:txBody>
+      </p:sp>
+      <p:sp>
+        <p:nvSpPr>
+          <p:cNvPr id="9" name="Principle card 2"/>
+          <p:cNvSpPr/>
+          <p:nvPr/>
+        </p:nvSpPr>
+        <p:spPr>
+          <a:xfrm>
+            <a:off x="4297679" y="1600200"/>
+            <a:ext cx="3474720" cy="2011680"/>
+          </a:xfrm>
+          <a:prstGeom prst="roundRect">
+            <a:avLst>
+              <a:gd name="adj" fmla="val 8000"/>
+            </a:avLst>
+          </a:prstGeom>
+          <a:solidFill>
+            <a:srgbClr val="FFFFFF"/>
+          </a:solidFill>
+          <a:ln w="12700">
+            <a:solidFill>
+              <a:srgbClr val="D5DBDF"/>
+            </a:solidFill>
+          </a:ln>
+          <a:effectLst/>
+        </p:spPr>
+        <p:style>
+          <a:lnRef idx="1">
+            <a:schemeClr val="accent1"/>
+          </a:lnRef>
+          <a:fillRef idx="3">
+            <a:schemeClr val="accent1"/>
+          </a:fillRef>
+          <a:effectRef idx="2">
+            <a:schemeClr val="accent1"/>
+          </a:effectRef>
+          <a:fontRef idx="minor">
+            <a:schemeClr val="lt1"/>
+          </a:fontRef>
+        </p:style>
+        <p:txBody>
+          <a:bodyPr rtlCol="0" anchor="ctr"/>
+          <a:lstStyle/>
+          <a:p/>
+        </p:txBody>
+      </p:sp>
+      <p:sp>
+        <p:nvSpPr>
+          <p:cNvPr id="10" name="Oval 9"/>
+          <p:cNvSpPr/>
+          <p:nvPr/>
+        </p:nvSpPr>
+        <p:spPr>
+          <a:xfrm>
+            <a:off x="4526279" y="1828800"/>
+            <a:ext cx="548640" cy="548640"/>
+          </a:xfrm>
+          <a:prstGeom prst="ellipse">
+            <a:avLst/>
+          </a:prstGeom>
+          <a:solidFill>
+            <a:srgbClr val="15607A"/>
+          </a:solidFill>
+          <a:ln>
+            <a:noFill/>
+          </a:ln>
+          <a:effectLst/>
+        </p:spPr>
+        <p:style>
+          <a:lnRef idx="1">
+            <a:schemeClr val="accent1"/>
+          </a:lnRef>
+          <a:fillRef idx="3">
+            <a:schemeClr val="accent1"/>
+          </a:fillRef>
+          <a:effectRef idx="2">
+            <a:schemeClr val="accent1"/>
+          </a:effectRef>
+          <a:fontRef idx="minor">
+            <a:schemeClr val="lt1"/>
+          </a:fontRef>
+        </p:style>
+        <p:txBody>
+          <a:bodyPr rtlCol="0" anchor="ctr" lIns="0" rIns="0" tIns="0" bIns="0"/>
+          <a:lstStyle/>
+          <a:p>
+            <a:pPr algn="ctr"/>
+            <a:r>
+              <a:rPr sz="1800" b="1">
+                <a:solidFill>
+                  <a:srgbClr val="FFFFFF"/>
+                </a:solidFill>
+                <a:latin typeface="Calibri"/>
+              </a:rPr>
+              <a:t>2</a:t>
+            </a:r>
+          </a:p>
+        </p:txBody>
+      </p:sp>
+      <p:sp>
+        <p:nvSpPr>
+          <p:cNvPr id="11" name="TextBox 10"/>
+          <p:cNvSpPr txBox="1"/>
+          <p:nvPr/>
+        </p:nvSpPr>
+        <p:spPr>
+          <a:xfrm>
+            <a:off x="5212079" y="1828800"/>
+            <a:ext cx="2423160" cy="548640"/>
+          </a:xfrm>
+          <a:prstGeom prst="rect">
+            <a:avLst/>
+          </a:prstGeom>
+          <a:noFill/>
+        </p:spPr>
+        <p:txBody>
+          <a:bodyPr wrap="square" lIns="0" rIns="0" tIns="0" bIns="0" anchor="ctr">
+            <a:spAutoFit/>
+          </a:bodyPr>
+          <a:lstStyle/>
+          <a:p>
+            <a:pPr algn="l"/>
+            <a:r>
+              <a:rPr sz="1700" b="1" i="0">
+                <a:solidFill>
+                  <a:srgbClr val="15607A"/>
+                </a:solidFill>
+                <a:latin typeface="Calibri"/>
+              </a:rPr>
+              <a:t>Manage connectivity</a:t>
+            </a:r>
+          </a:p>
+        </p:txBody>
+      </p:sp>
+      <p:sp>
+        <p:nvSpPr>
+          <p:cNvPr id="12" name="Sign 2"/>
+          <p:cNvSpPr/>
+          <p:nvPr/>
+        </p:nvSpPr>
+        <p:spPr>
+          <a:xfrm>
+            <a:off x="4526279" y="2624328"/>
+            <a:ext cx="347472" cy="347472"/>
+          </a:xfrm>
+          <a:prstGeom prst="ellipse">
+            <a:avLst/>
+          </a:prstGeom>
+          <a:solidFill>
+            <a:srgbClr val="E26E24"/>
+          </a:solidFill>
+          <a:ln>
+            <a:noFill/>
+          </a:ln>
+          <a:effectLst/>
+        </p:spPr>
+        <p:style>
+          <a:lnRef idx="1">
+            <a:schemeClr val="accent1"/>
+          </a:lnRef>
+          <a:fillRef idx="3">
+            <a:schemeClr val="accent1"/>
+          </a:fillRef>
+          <a:effectRef idx="2">
+            <a:schemeClr val="accent1"/>
+          </a:effectRef>
+          <a:fontRef idx="minor">
+            <a:schemeClr val="lt1"/>
+          </a:fontRef>
+        </p:style>
+        <p:txBody>
+          <a:bodyPr rtlCol="0" anchor="ctr" lIns="0" rIns="0" tIns="0" bIns="0"/>
+          <a:lstStyle/>
+          <a:p>
+            <a:pPr algn="ctr"/>
+            <a:r>
+              <a:rPr sz="1600" b="1">
+                <a:solidFill>
+                  <a:srgbClr val="FFFFFF"/>
+                </a:solidFill>
+                <a:latin typeface="Calibri"/>
+              </a:rPr>
+              <a:t>–</a:t>
+            </a:r>
+          </a:p>
+        </p:txBody>
+      </p:sp>
+      <p:sp>
+        <p:nvSpPr>
+          <p:cNvPr id="13" name="TextBox 12"/>
+          <p:cNvSpPr txBox="1"/>
+          <p:nvPr/>
+        </p:nvSpPr>
+        <p:spPr>
+          <a:xfrm>
+            <a:off x="5029199" y="2514600"/>
+            <a:ext cx="2606040" cy="1005840"/>
+          </a:xfrm>
+          <a:prstGeom prst="rect">
+            <a:avLst/>
+          </a:prstGeom>
+          <a:noFill/>
+        </p:spPr>
+        <p:txBody>
+          <a:bodyPr wrap="square" lIns="0" rIns="0" tIns="0" bIns="0" anchor="t">
+            <a:spAutoFit/>
+          </a:bodyPr>
+          <a:lstStyle/>
+          <a:p>
+            <a:pPr algn="l"/>
+            <a:r>
+              <a:rPr sz="1400" b="0" i="0">
+                <a:solidFill>
+                  <a:srgbClr val="222B33"/>
+                </a:solidFill>
+                <a:latin typeface="Calibri"/>
+              </a:rPr>
+              <a:t>2007–08: rice export bans, Viet Nam's included, turned a well-supplied market into a price spike</a:t>
+            </a:r>
+          </a:p>
+        </p:txBody>
+      </p:sp>
+      <p:sp>
+        <p:nvSpPr>
+          <p:cNvPr id="14" name="Principle card 3"/>
+          <p:cNvSpPr/>
+          <p:nvPr/>
+        </p:nvSpPr>
+        <p:spPr>
+          <a:xfrm>
+            <a:off x="8046719" y="1600200"/>
+            <a:ext cx="3474720" cy="2011680"/>
+          </a:xfrm>
+          <a:prstGeom prst="roundRect">
+            <a:avLst>
+              <a:gd name="adj" fmla="val 8000"/>
+            </a:avLst>
+          </a:prstGeom>
+          <a:solidFill>
+            <a:srgbClr val="FFFFFF"/>
+          </a:solidFill>
+          <a:ln w="12700">
+            <a:solidFill>
+              <a:srgbClr val="D5DBDF"/>
+            </a:solidFill>
+          </a:ln>
+          <a:effectLst/>
+        </p:spPr>
+        <p:style>
+          <a:lnRef idx="1">
+            <a:schemeClr val="accent1"/>
+          </a:lnRef>
+          <a:fillRef idx="3">
+            <a:schemeClr val="accent1"/>
+          </a:fillRef>
+          <a:effectRef idx="2">
+            <a:schemeClr val="accent1"/>
+          </a:effectRef>
+          <a:fontRef idx="minor">
+            <a:schemeClr val="lt1"/>
+          </a:fontRef>
+        </p:style>
+        <p:txBody>
+          <a:bodyPr rtlCol="0" anchor="ctr"/>
+          <a:lstStyle/>
+          <a:p/>
+        </p:txBody>
+      </p:sp>
+      <p:sp>
+        <p:nvSpPr>
+          <p:cNvPr id="15" name="Oval 14"/>
+          <p:cNvSpPr/>
+          <p:nvPr/>
+        </p:nvSpPr>
+        <p:spPr>
+          <a:xfrm>
+            <a:off x="8275319" y="1828800"/>
+            <a:ext cx="548640" cy="548640"/>
+          </a:xfrm>
+          <a:prstGeom prst="ellipse">
+            <a:avLst/>
+          </a:prstGeom>
+          <a:solidFill>
+            <a:srgbClr val="15607A"/>
+          </a:solidFill>
+          <a:ln>
+            <a:noFill/>
+          </a:ln>
+          <a:effectLst/>
+        </p:spPr>
+        <p:style>
+          <a:lnRef idx="1">
+            <a:schemeClr val="accent1"/>
+          </a:lnRef>
+          <a:fillRef idx="3">
+            <a:schemeClr val="accent1"/>
+          </a:fillRef>
+          <a:effectRef idx="2">
+            <a:schemeClr val="accent1"/>
+          </a:effectRef>
+          <a:fontRef idx="minor">
+            <a:schemeClr val="lt1"/>
+          </a:fontRef>
+        </p:style>
+        <p:txBody>
+          <a:bodyPr rtlCol="0" anchor="ctr" lIns="0" rIns="0" tIns="0" bIns="0"/>
+          <a:lstStyle/>
+          <a:p>
+            <a:pPr algn="ctr"/>
+            <a:r>
+              <a:rPr sz="1800" b="1">
+                <a:solidFill>
+                  <a:srgbClr val="FFFFFF"/>
+                </a:solidFill>
+                <a:latin typeface="Calibri"/>
+              </a:rPr>
+              <a:t>3</a:t>
+            </a:r>
+          </a:p>
+        </p:txBody>
+      </p:sp>
+      <p:sp>
+        <p:nvSpPr>
+          <p:cNvPr id="16" name="TextBox 15"/>
+          <p:cNvSpPr txBox="1"/>
+          <p:nvPr/>
+        </p:nvSpPr>
+        <p:spPr>
+          <a:xfrm>
+            <a:off x="8961119" y="1828800"/>
+            <a:ext cx="2423160" cy="548640"/>
+          </a:xfrm>
+          <a:prstGeom prst="rect">
+            <a:avLst/>
+          </a:prstGeom>
+          <a:noFill/>
+        </p:spPr>
+        <p:txBody>
+          <a:bodyPr wrap="square" lIns="0" rIns="0" tIns="0" bIns="0" anchor="ctr">
+            <a:spAutoFit/>
+          </a:bodyPr>
+          <a:lstStyle/>
+          <a:p>
+            <a:pPr algn="l"/>
+            <a:r>
+              <a:rPr sz="1700" b="1" i="0">
+                <a:solidFill>
+                  <a:srgbClr val="15607A"/>
+                </a:solidFill>
+                <a:latin typeface="Calibri"/>
+              </a:rPr>
+              <a:t>Watch slow variables</a:t>
+            </a:r>
+          </a:p>
+        </p:txBody>
+      </p:sp>
+      <p:sp>
+        <p:nvSpPr>
+          <p:cNvPr id="17" name="Sign 3"/>
+          <p:cNvSpPr/>
+          <p:nvPr/>
+        </p:nvSpPr>
+        <p:spPr>
+          <a:xfrm>
+            <a:off x="8275319" y="2624328"/>
+            <a:ext cx="347472" cy="347472"/>
+          </a:xfrm>
+          <a:prstGeom prst="ellipse">
+            <a:avLst/>
+          </a:prstGeom>
+          <a:solidFill>
+            <a:srgbClr val="E26E24"/>
+          </a:solidFill>
+          <a:ln>
+            <a:noFill/>
+          </a:ln>
+          <a:effectLst/>
+        </p:spPr>
+        <p:style>
+          <a:lnRef idx="1">
+            <a:schemeClr val="accent1"/>
+          </a:lnRef>
+          <a:fillRef idx="3">
+            <a:schemeClr val="accent1"/>
+          </a:fillRef>
+          <a:effectRef idx="2">
+            <a:schemeClr val="accent1"/>
+          </a:effectRef>
+          <a:fontRef idx="minor">
+            <a:schemeClr val="lt1"/>
+          </a:fontRef>
+        </p:style>
+        <p:txBody>
+          <a:bodyPr rtlCol="0" anchor="ctr" lIns="0" rIns="0" tIns="0" bIns="0"/>
+          <a:lstStyle/>
+          <a:p>
+            <a:pPr algn="ctr"/>
+            <a:r>
+              <a:rPr sz="1600" b="1">
+                <a:solidFill>
+                  <a:srgbClr val="FFFFFF"/>
+                </a:solidFill>
+                <a:latin typeface="Calibri"/>
+              </a:rPr>
+              <a:t>–</a:t>
+            </a:r>
+          </a:p>
+        </p:txBody>
+      </p:sp>
+      <p:sp>
+        <p:nvSpPr>
+          <p:cNvPr id="18" name="TextBox 17"/>
+          <p:cNvSpPr txBox="1"/>
+          <p:nvPr/>
+        </p:nvSpPr>
+        <p:spPr>
+          <a:xfrm>
+            <a:off x="8778240" y="2514600"/>
+            <a:ext cx="2606040" cy="1005840"/>
+          </a:xfrm>
+          <a:prstGeom prst="rect">
+            <a:avLst/>
+          </a:prstGeom>
+          <a:noFill/>
+        </p:spPr>
+        <p:txBody>
+          <a:bodyPr wrap="square" lIns="0" rIns="0" tIns="0" bIns="0" anchor="t">
+            <a:spAutoFit/>
+          </a:bodyPr>
+          <a:lstStyle/>
+          <a:p>
+            <a:pPr algn="l"/>
+            <a:r>
+              <a:rPr sz="1400" b="0" i="0">
+                <a:solidFill>
+                  <a:srgbClr val="222B33"/>
+                </a:solidFill>
+                <a:latin typeface="Calibri"/>
+              </a:rPr>
+              <a:t>Mekong Delta: rising salinity, while rice-oriented policy makes switching systems harder</a:t>
+            </a:r>
+          </a:p>
+        </p:txBody>
+      </p:sp>
+      <p:sp>
+        <p:nvSpPr>
+          <p:cNvPr id="19" name="Principle card 4"/>
+          <p:cNvSpPr/>
+          <p:nvPr/>
+        </p:nvSpPr>
+        <p:spPr>
+          <a:xfrm>
+            <a:off x="548640" y="3840480"/>
+            <a:ext cx="3474720" cy="2011680"/>
+          </a:xfrm>
+          <a:prstGeom prst="roundRect">
+            <a:avLst>
+              <a:gd name="adj" fmla="val 8000"/>
+            </a:avLst>
+          </a:prstGeom>
+          <a:solidFill>
+            <a:srgbClr val="FFFFFF"/>
+          </a:solidFill>
+          <a:ln w="12700">
+            <a:solidFill>
+              <a:srgbClr val="D5DBDF"/>
+            </a:solidFill>
+          </a:ln>
+          <a:effectLst/>
+        </p:spPr>
+        <p:style>
+          <a:lnRef idx="1">
+            <a:schemeClr val="accent1"/>
+          </a:lnRef>
+          <a:fillRef idx="3">
+            <a:schemeClr val="accent1"/>
+          </a:fillRef>
+          <a:effectRef idx="2">
+            <a:schemeClr val="accent1"/>
+          </a:effectRef>
+          <a:fontRef idx="minor">
+            <a:schemeClr val="lt1"/>
+          </a:fontRef>
+        </p:style>
+        <p:txBody>
+          <a:bodyPr rtlCol="0" anchor="ctr"/>
+          <a:lstStyle/>
+          <a:p/>
+        </p:txBody>
+      </p:sp>
+      <p:sp>
+        <p:nvSpPr>
+          <p:cNvPr id="20" name="Oval 19"/>
+          <p:cNvSpPr/>
+          <p:nvPr/>
+        </p:nvSpPr>
+        <p:spPr>
+          <a:xfrm>
+            <a:off x="777240" y="4069080"/>
+            <a:ext cx="548640" cy="548640"/>
+          </a:xfrm>
+          <a:prstGeom prst="ellipse">
+            <a:avLst/>
+          </a:prstGeom>
+          <a:solidFill>
+            <a:srgbClr val="15607A"/>
+          </a:solidFill>
+          <a:ln>
+            <a:noFill/>
+          </a:ln>
+          <a:effectLst/>
+        </p:spPr>
+        <p:style>
+          <a:lnRef idx="1">
+            <a:schemeClr val="accent1"/>
+          </a:lnRef>
+          <a:fillRef idx="3">
+            <a:schemeClr val="accent1"/>
+          </a:fillRef>
+          <a:effectRef idx="2">
+            <a:schemeClr val="accent1"/>
+          </a:effectRef>
+          <a:fontRef idx="minor">
+            <a:schemeClr val="lt1"/>
+          </a:fontRef>
+        </p:style>
+        <p:txBody>
+          <a:bodyPr rtlCol="0" anchor="ctr" lIns="0" rIns="0" tIns="0" bIns="0"/>
+          <a:lstStyle/>
+          <a:p>
+            <a:pPr algn="ctr"/>
+            <a:r>
+              <a:rPr sz="1800" b="1">
+                <a:solidFill>
+                  <a:srgbClr val="FFFFFF"/>
+                </a:solidFill>
+                <a:latin typeface="Calibri"/>
+              </a:rPr>
+              <a:t>4</a:t>
+            </a:r>
+          </a:p>
+        </p:txBody>
+      </p:sp>
+      <p:sp>
+        <p:nvSpPr>
+          <p:cNvPr id="21" name="TextBox 20"/>
+          <p:cNvSpPr txBox="1"/>
+          <p:nvPr/>
+        </p:nvSpPr>
+        <p:spPr>
+          <a:xfrm>
+            <a:off x="1463040" y="4069080"/>
+            <a:ext cx="2423160" cy="548640"/>
+          </a:xfrm>
+          <a:prstGeom prst="rect">
+            <a:avLst/>
+          </a:prstGeom>
+          <a:noFill/>
+        </p:spPr>
+        <p:txBody>
+          <a:bodyPr wrap="square" lIns="0" rIns="0" tIns="0" bIns="0" anchor="ctr">
+            <a:spAutoFit/>
+          </a:bodyPr>
+          <a:lstStyle/>
+          <a:p>
+            <a:pPr algn="l"/>
+            <a:r>
+              <a:rPr sz="1700" b="1" i="0">
+                <a:solidFill>
+                  <a:srgbClr val="15607A"/>
+                </a:solidFill>
+                <a:latin typeface="Calibri"/>
+              </a:rPr>
+              <a:t>Learn and experiment</a:t>
+            </a:r>
+          </a:p>
+        </p:txBody>
+      </p:sp>
+      <p:sp>
+        <p:nvSpPr>
+          <p:cNvPr id="22" name="Sign 4"/>
+          <p:cNvSpPr/>
+          <p:nvPr/>
+        </p:nvSpPr>
+        <p:spPr>
+          <a:xfrm>
+            <a:off x="777240" y="4864608"/>
+            <a:ext cx="347472" cy="347472"/>
+          </a:xfrm>
+          <a:prstGeom prst="ellipse">
+            <a:avLst/>
+          </a:prstGeom>
+          <a:solidFill>
+            <a:srgbClr val="4E8F3A"/>
+          </a:solidFill>
+          <a:ln>
+            <a:noFill/>
+          </a:ln>
+          <a:effectLst/>
+        </p:spPr>
+        <p:style>
+          <a:lnRef idx="1">
+            <a:schemeClr val="accent1"/>
+          </a:lnRef>
+          <a:fillRef idx="3">
+            <a:schemeClr val="accent1"/>
+          </a:fillRef>
+          <a:effectRef idx="2">
+            <a:schemeClr val="accent1"/>
+          </a:effectRef>
+          <a:fontRef idx="minor">
+            <a:schemeClr val="lt1"/>
+          </a:fontRef>
+        </p:style>
+        <p:txBody>
+          <a:bodyPr rtlCol="0" anchor="ctr" lIns="0" rIns="0" tIns="0" bIns="0"/>
+          <a:lstStyle/>
+          <a:p>
+            <a:pPr algn="ctr"/>
+            <a:r>
+              <a:rPr sz="1600" b="1">
+                <a:solidFill>
+                  <a:srgbClr val="FFFFFF"/>
+                </a:solidFill>
+                <a:latin typeface="Calibri"/>
+              </a:rPr>
+              <a:t>+</a:t>
+            </a:r>
+          </a:p>
+        </p:txBody>
+      </p:sp>
+      <p:sp>
+        <p:nvSpPr>
+          <p:cNvPr id="23" name="TextBox 22"/>
+          <p:cNvSpPr txBox="1"/>
+          <p:nvPr/>
+        </p:nvSpPr>
+        <p:spPr>
+          <a:xfrm>
+            <a:off x="1280160" y="4754880"/>
+            <a:ext cx="2606040" cy="1005840"/>
+          </a:xfrm>
+          <a:prstGeom prst="rect">
+            <a:avLst/>
+          </a:prstGeom>
+          <a:noFill/>
+        </p:spPr>
+        <p:txBody>
+          <a:bodyPr wrap="square" lIns="0" rIns="0" tIns="0" bIns="0" anchor="t">
+            <a:spAutoFit/>
+          </a:bodyPr>
+          <a:lstStyle/>
+          <a:p>
+            <a:pPr algn="l"/>
+            <a:r>
+              <a:rPr sz="1400" b="0" i="0">
+                <a:solidFill>
+                  <a:srgbClr val="222B33"/>
+                </a:solidFill>
+                <a:latin typeface="Calibri"/>
+              </a:rPr>
+              <a:t>Son La and Dong Thap: food system profiles and pilots before a provincial plan</a:t>
+            </a:r>
+          </a:p>
+        </p:txBody>
+      </p:sp>
+      <p:sp>
+        <p:nvSpPr>
+          <p:cNvPr id="24" name="Principle card 5"/>
+          <p:cNvSpPr/>
+          <p:nvPr/>
+        </p:nvSpPr>
+        <p:spPr>
+          <a:xfrm>
+            <a:off x="4297679" y="3840480"/>
+            <a:ext cx="3474720" cy="2011680"/>
+          </a:xfrm>
+          <a:prstGeom prst="roundRect">
+            <a:avLst>
+              <a:gd name="adj" fmla="val 8000"/>
+            </a:avLst>
+          </a:prstGeom>
+          <a:solidFill>
+            <a:srgbClr val="FFFFFF"/>
+          </a:solidFill>
+          <a:ln w="12700">
+            <a:solidFill>
+              <a:srgbClr val="D5DBDF"/>
+            </a:solidFill>
+          </a:ln>
+          <a:effectLst/>
+        </p:spPr>
+        <p:style>
+          <a:lnRef idx="1">
+            <a:schemeClr val="accent1"/>
+          </a:lnRef>
+          <a:fillRef idx="3">
+            <a:schemeClr val="accent1"/>
+          </a:fillRef>
+          <a:effectRef idx="2">
+            <a:schemeClr val="accent1"/>
+          </a:effectRef>
+          <a:fontRef idx="minor">
+            <a:schemeClr val="lt1"/>
+          </a:fontRef>
+        </p:style>
+        <p:txBody>
+          <a:bodyPr rtlCol="0" anchor="ctr"/>
+          <a:lstStyle/>
+          <a:p/>
+        </p:txBody>
+      </p:sp>
+      <p:sp>
+        <p:nvSpPr>
+          <p:cNvPr id="25" name="Oval 24"/>
+          <p:cNvSpPr/>
+          <p:nvPr/>
+        </p:nvSpPr>
+        <p:spPr>
+          <a:xfrm>
+            <a:off x="4526279" y="4069080"/>
+            <a:ext cx="548640" cy="548640"/>
+          </a:xfrm>
+          <a:prstGeom prst="ellipse">
+            <a:avLst/>
+          </a:prstGeom>
+          <a:solidFill>
+            <a:srgbClr val="15607A"/>
+          </a:solidFill>
+          <a:ln>
+            <a:noFill/>
+          </a:ln>
+          <a:effectLst/>
+        </p:spPr>
+        <p:style>
+          <a:lnRef idx="1">
+            <a:schemeClr val="accent1"/>
+          </a:lnRef>
+          <a:fillRef idx="3">
+            <a:schemeClr val="accent1"/>
+          </a:fillRef>
+          <a:effectRef idx="2">
+            <a:schemeClr val="accent1"/>
+          </a:effectRef>
+          <a:fontRef idx="minor">
+            <a:schemeClr val="lt1"/>
+          </a:fontRef>
+        </p:style>
+        <p:txBody>
+          <a:bodyPr rtlCol="0" anchor="ctr" lIns="0" rIns="0" tIns="0" bIns="0"/>
+          <a:lstStyle/>
+          <a:p>
+            <a:pPr algn="ctr"/>
+            <a:r>
+              <a:rPr sz="1800" b="1">
+                <a:solidFill>
+                  <a:srgbClr val="FFFFFF"/>
+                </a:solidFill>
+                <a:latin typeface="Calibri"/>
+              </a:rPr>
+              <a:t>5</a:t>
+            </a:r>
+          </a:p>
+        </p:txBody>
+      </p:sp>
+      <p:sp>
+        <p:nvSpPr>
+          <p:cNvPr id="26" name="TextBox 25"/>
+          <p:cNvSpPr txBox="1"/>
+          <p:nvPr/>
+        </p:nvSpPr>
+        <p:spPr>
+          <a:xfrm>
+            <a:off x="5212079" y="4069080"/>
+            <a:ext cx="2423160" cy="548640"/>
+          </a:xfrm>
+          <a:prstGeom prst="rect">
+            <a:avLst/>
+          </a:prstGeom>
+          <a:noFill/>
+        </p:spPr>
+        <p:txBody>
+          <a:bodyPr wrap="square" lIns="0" rIns="0" tIns="0" bIns="0" anchor="ctr">
+            <a:spAutoFit/>
+          </a:bodyPr>
+          <a:lstStyle/>
+          <a:p>
+            <a:pPr algn="l"/>
+            <a:r>
+              <a:rPr sz="1700" b="1" i="0">
+                <a:solidFill>
+                  <a:srgbClr val="15607A"/>
+                </a:solidFill>
+                <a:latin typeface="Calibri"/>
+              </a:rPr>
+              <a:t>Broaden participation</a:t>
+            </a:r>
+          </a:p>
+        </p:txBody>
+      </p:sp>
+      <p:sp>
+        <p:nvSpPr>
+          <p:cNvPr id="27" name="Sign 5"/>
+          <p:cNvSpPr/>
+          <p:nvPr/>
+        </p:nvSpPr>
+        <p:spPr>
+          <a:xfrm>
+            <a:off x="4526279" y="4864608"/>
+            <a:ext cx="347472" cy="347472"/>
+          </a:xfrm>
+          <a:prstGeom prst="ellipse">
+            <a:avLst/>
+          </a:prstGeom>
+          <a:solidFill>
+            <a:srgbClr val="E26E24"/>
+          </a:solidFill>
+          <a:ln>
+            <a:noFill/>
+          </a:ln>
+          <a:effectLst/>
+        </p:spPr>
+        <p:style>
+          <a:lnRef idx="1">
+            <a:schemeClr val="accent1"/>
+          </a:lnRef>
+          <a:fillRef idx="3">
+            <a:schemeClr val="accent1"/>
+          </a:fillRef>
+          <a:effectRef idx="2">
+            <a:schemeClr val="accent1"/>
+          </a:effectRef>
+          <a:fontRef idx="minor">
+            <a:schemeClr val="lt1"/>
+          </a:fontRef>
+        </p:style>
+        <p:txBody>
+          <a:bodyPr rtlCol="0" anchor="ctr" lIns="0" rIns="0" tIns="0" bIns="0"/>
+          <a:lstStyle/>
+          <a:p>
+            <a:pPr algn="ctr"/>
+            <a:r>
+              <a:rPr sz="1600" b="1">
+                <a:solidFill>
+                  <a:srgbClr val="FFFFFF"/>
+                </a:solidFill>
+                <a:latin typeface="Calibri"/>
+              </a:rPr>
+              <a:t>–</a:t>
+            </a:r>
+          </a:p>
+        </p:txBody>
+      </p:sp>
+      <p:sp>
+        <p:nvSpPr>
+          <p:cNvPr id="28" name="TextBox 27"/>
+          <p:cNvSpPr txBox="1"/>
+          <p:nvPr/>
+        </p:nvSpPr>
+        <p:spPr>
+          <a:xfrm>
+            <a:off x="5029199" y="4754880"/>
+            <a:ext cx="2606040" cy="1005840"/>
+          </a:xfrm>
+          <a:prstGeom prst="rect">
+            <a:avLst/>
+          </a:prstGeom>
+          <a:noFill/>
+        </p:spPr>
+        <p:txBody>
+          <a:bodyPr wrap="square" lIns="0" rIns="0" tIns="0" bIns="0" anchor="t">
+            <a:spAutoFit/>
+          </a:bodyPr>
+          <a:lstStyle/>
+          <a:p>
+            <a:pPr algn="l"/>
+            <a:r>
+              <a:rPr sz="1400" b="0" i="0">
+                <a:solidFill>
+                  <a:srgbClr val="222B33"/>
+                </a:solidFill>
+                <a:latin typeface="Calibri"/>
+              </a:rPr>
+              <a:t>Ca Mau: resource policies built on control did not raise household resilience</a:t>
+            </a:r>
+          </a:p>
+        </p:txBody>
+      </p:sp>
+      <p:sp>
+        <p:nvSpPr>
+          <p:cNvPr id="29" name="Principle card 6"/>
+          <p:cNvSpPr/>
+          <p:nvPr/>
+        </p:nvSpPr>
+        <p:spPr>
+          <a:xfrm>
+            <a:off x="8046719" y="3840480"/>
+            <a:ext cx="3474720" cy="2011680"/>
+          </a:xfrm>
+          <a:prstGeom prst="roundRect">
+            <a:avLst>
+              <a:gd name="adj" fmla="val 8000"/>
+            </a:avLst>
+          </a:prstGeom>
+          <a:solidFill>
+            <a:srgbClr val="FFFFFF"/>
+          </a:solidFill>
+          <a:ln w="12700">
+            <a:solidFill>
+              <a:srgbClr val="D5DBDF"/>
+            </a:solidFill>
+          </a:ln>
+          <a:effectLst/>
+        </p:spPr>
+        <p:style>
+          <a:lnRef idx="1">
+            <a:schemeClr val="accent1"/>
+          </a:lnRef>
+          <a:fillRef idx="3">
+            <a:schemeClr val="accent1"/>
+          </a:fillRef>
+          <a:effectRef idx="2">
+            <a:schemeClr val="accent1"/>
+          </a:effectRef>
+          <a:fontRef idx="minor">
+            <a:schemeClr val="lt1"/>
+          </a:fontRef>
+        </p:style>
+        <p:txBody>
+          <a:bodyPr rtlCol="0" anchor="ctr"/>
+          <a:lstStyle/>
+          <a:p/>
+        </p:txBody>
+      </p:sp>
+      <p:sp>
+        <p:nvSpPr>
+          <p:cNvPr id="30" name="Oval 29"/>
+          <p:cNvSpPr/>
+          <p:nvPr/>
+        </p:nvSpPr>
+        <p:spPr>
+          <a:xfrm>
+            <a:off x="8275319" y="4069080"/>
+            <a:ext cx="548640" cy="548640"/>
+          </a:xfrm>
+          <a:prstGeom prst="ellipse">
+            <a:avLst/>
+          </a:prstGeom>
+          <a:solidFill>
+            <a:srgbClr val="15607A"/>
+          </a:solidFill>
+          <a:ln>
+            <a:noFill/>
+          </a:ln>
+          <a:effectLst/>
+        </p:spPr>
+        <p:style>
+          <a:lnRef idx="1">
+            <a:schemeClr val="accent1"/>
+          </a:lnRef>
+          <a:fillRef idx="3">
+            <a:schemeClr val="accent1"/>
+          </a:fillRef>
+          <a:effectRef idx="2">
+            <a:schemeClr val="accent1"/>
+          </a:effectRef>
+          <a:fontRef idx="minor">
+            <a:schemeClr val="lt1"/>
+          </a:fontRef>
+        </p:style>
+        <p:txBody>
+          <a:bodyPr rtlCol="0" anchor="ctr" lIns="0" rIns="0" tIns="0" bIns="0"/>
+          <a:lstStyle/>
+          <a:p>
+            <a:pPr algn="ctr"/>
+            <a:r>
+              <a:rPr sz="1800" b="1">
+                <a:solidFill>
+                  <a:srgbClr val="FFFFFF"/>
+                </a:solidFill>
+                <a:latin typeface="Calibri"/>
+              </a:rPr>
+              <a:t>6</a:t>
+            </a:r>
+          </a:p>
+        </p:txBody>
+      </p:sp>
+      <p:sp>
+        <p:nvSpPr>
+          <p:cNvPr id="31" name="TextBox 30"/>
+          <p:cNvSpPr txBox="1"/>
+          <p:nvPr/>
+        </p:nvSpPr>
+        <p:spPr>
+          <a:xfrm>
+            <a:off x="8961119" y="4069080"/>
+            <a:ext cx="2423160" cy="548640"/>
+          </a:xfrm>
+          <a:prstGeom prst="rect">
+            <a:avLst/>
+          </a:prstGeom>
+          <a:noFill/>
+        </p:spPr>
+        <p:txBody>
+          <a:bodyPr wrap="square" lIns="0" rIns="0" tIns="0" bIns="0" anchor="ctr">
+            <a:spAutoFit/>
+          </a:bodyPr>
+          <a:lstStyle/>
+          <a:p>
+            <a:pPr algn="l"/>
+            <a:r>
+              <a:rPr sz="1700" b="1" i="0">
+                <a:solidFill>
+                  <a:srgbClr val="15607A"/>
+                </a:solidFill>
+                <a:latin typeface="Calibri"/>
+              </a:rPr>
+              <a:t>Share governance</a:t>
+            </a:r>
+          </a:p>
+        </p:txBody>
+      </p:sp>
+      <p:sp>
+        <p:nvSpPr>
+          <p:cNvPr id="32" name="Sign 6"/>
+          <p:cNvSpPr/>
+          <p:nvPr/>
+        </p:nvSpPr>
+        <p:spPr>
+          <a:xfrm>
+            <a:off x="8275319" y="4864608"/>
+            <a:ext cx="347472" cy="347472"/>
+          </a:xfrm>
+          <a:prstGeom prst="ellipse">
+            <a:avLst/>
+          </a:prstGeom>
+          <a:solidFill>
+            <a:srgbClr val="4E8F3A"/>
+          </a:solidFill>
+          <a:ln>
+            <a:noFill/>
+          </a:ln>
+          <a:effectLst/>
+        </p:spPr>
+        <p:style>
+          <a:lnRef idx="1">
+            <a:schemeClr val="accent1"/>
+          </a:lnRef>
+          <a:fillRef idx="3">
+            <a:schemeClr val="accent1"/>
+          </a:fillRef>
+          <a:effectRef idx="2">
+            <a:schemeClr val="accent1"/>
+          </a:effectRef>
+          <a:fontRef idx="minor">
+            <a:schemeClr val="lt1"/>
+          </a:fontRef>
+        </p:style>
+        <p:txBody>
+          <a:bodyPr rtlCol="0" anchor="ctr" lIns="0" rIns="0" tIns="0" bIns="0"/>
+          <a:lstStyle/>
+          <a:p>
+            <a:pPr algn="ctr"/>
+            <a:r>
+              <a:rPr sz="1600" b="1">
+                <a:solidFill>
+                  <a:srgbClr val="FFFFFF"/>
+                </a:solidFill>
+                <a:latin typeface="Calibri"/>
+              </a:rPr>
+              <a:t>+</a:t>
+            </a:r>
+          </a:p>
+        </p:txBody>
+      </p:sp>
+      <p:sp>
+        <p:nvSpPr>
+          <p:cNvPr id="33" name="TextBox 32"/>
+          <p:cNvSpPr txBox="1"/>
+          <p:nvPr/>
+        </p:nvSpPr>
+        <p:spPr>
+          <a:xfrm>
+            <a:off x="8778240" y="4754880"/>
+            <a:ext cx="2606040" cy="1005840"/>
+          </a:xfrm>
+          <a:prstGeom prst="rect">
+            <a:avLst/>
+          </a:prstGeom>
+          <a:noFill/>
+        </p:spPr>
+        <p:txBody>
+          <a:bodyPr wrap="square" lIns="0" rIns="0" tIns="0" bIns="0" anchor="t">
+            <a:spAutoFit/>
+          </a:bodyPr>
+          <a:lstStyle/>
+          <a:p>
+            <a:pPr algn="l"/>
+            <a:r>
+              <a:rPr sz="1400" b="0" i="0">
+                <a:solidFill>
+                  <a:srgbClr val="222B33"/>
+                </a:solidFill>
+                <a:latin typeface="Calibri"/>
+              </a:rPr>
+              <a:t>NAP-FST links ministries, provinces and the FST-Partnership, but local funding is thin</a:t>
+            </a:r>
+          </a:p>
+        </p:txBody>
+      </p:sp>
+      <p:sp>
+        <p:nvSpPr>
+          <p:cNvPr id="34" name="Source"/>
+          <p:cNvSpPr txBox="1"/>
+          <p:nvPr/>
+        </p:nvSpPr>
+        <p:spPr>
+          <a:xfrm>
+            <a:off x="548640" y="6355080"/>
+            <a:ext cx="11064240" cy="274320"/>
+          </a:xfrm>
+          <a:prstGeom prst="rect">
+            <a:avLst/>
+          </a:prstGeom>
+          <a:noFill/>
+        </p:spPr>
+        <p:txBody>
+          <a:bodyPr wrap="square" lIns="0" rIns="0" tIns="0" bIns="0" anchor="t">
+            <a:spAutoFit/>
+          </a:bodyPr>
+          <a:lstStyle/>
+          <a:p>
+            <a:pPr algn="l"/>
+            <a:r>
+              <a:rPr sz="1000" b="0" i="0">
+                <a:solidFill>
+                  <a:srgbClr val="6B757D"/>
+                </a:solidFill>
+                <a:latin typeface="Calibri"/>
+              </a:rPr>
+              <a:t>Sources: Biggs et al. (2012); Bruckert &amp; Nguyen (2024); Dawe &amp; Slayton (2011); Nguyen et al. (2019); Lundy et al. (2026); Tran (2012); MAE (2025)</a:t>
             </a:r>
           </a:p>
         </p:txBody>

</xml_diff>